<commit_message>
docs: add architecture slide to deck + transparent diagram
Co-Authored-By: Claude Opus 4.8 (1M context) <noreply@anthropic.com>
</commit_message>
<xml_diff>
--- a/deliverables/presentation.pptx
+++ b/deliverables/presentation.pptx
@@ -14,6 +14,7 @@
     <p:sldId id="256" r:id="rId14"/>
     <p:sldId id="257" r:id="rId15"/>
     <p:sldId id="258" r:id="rId16"/>
+    <p:sldId id="272" r:id="rId6"/>
     <p:sldId id="259" r:id="rId17"/>
     <p:sldId id="260" r:id="rId18"/>
     <p:sldId id="261" r:id="rId19"/>
@@ -40372,6 +40373,69 @@
 </p:sld>
 </file>
 
+<file path=ppt/slides/slide17.xml><?xml version="1.0" encoding="utf-8"?>
+<p:sld xmlns:a="http://schemas.openxmlformats.org/drawingml/2006/main" xmlns:p="http://schemas.openxmlformats.org/presentationml/2006/main" xmlns:r="http://schemas.openxmlformats.org/officeDocument/2006/relationships">
+  <p:cSld>
+    <p:spTree>
+      <p:nvGrpSpPr>
+        <p:cNvPr id="1" name=""/>
+        <p:cNvGrpSpPr/>
+        <p:nvPr/>
+      </p:nvGrpSpPr>
+      <p:grpSpPr/>
+      <p:sp>
+        <p:nvSpPr>
+          <p:cNvPr id="2" name="Title 1"/>
+          <p:cNvSpPr>
+            <a:spLocks noGrp="1"/>
+          </p:cNvSpPr>
+          <p:nvPr>
+            <p:ph type="title"/>
+          </p:nvPr>
+        </p:nvSpPr>
+        <p:spPr/>
+        <p:txBody>
+          <a:bodyPr/>
+          <a:lstStyle/>
+          <a:p>
+            <a:r>
+              <a:t>Architecture</a:t>
+            </a:r>
+          </a:p>
+        </p:txBody>
+      </p:sp>
+      <p:pic>
+        <p:nvPicPr>
+          <p:cNvPr id="3" name="Picture 2" descr="architecture.png"/>
+          <p:cNvPicPr>
+            <a:picLocks noChangeAspect="1"/>
+          </p:cNvPicPr>
+          <p:nvPr/>
+        </p:nvPicPr>
+        <p:blipFill>
+          <a:blip r:embed="rId2"/>
+          <a:stretch>
+            <a:fillRect/>
+          </a:stretch>
+        </p:blipFill>
+        <p:spPr>
+          <a:xfrm>
+            <a:off x="457200" y="3111569"/>
+            <a:ext cx="11277600" cy="1640701"/>
+          </a:xfrm>
+          <a:prstGeom prst="rect">
+            <a:avLst/>
+          </a:prstGeom>
+        </p:spPr>
+      </p:pic>
+    </p:spTree>
+  </p:cSld>
+  <p:clrMapOvr>
+    <a:masterClrMapping/>
+  </p:clrMapOvr>
+</p:sld>
+</file>
+
 <file path=ppt/slides/slide2.xml><?xml version="1.0" encoding="utf-8"?>
 <p:sld xmlns:a="http://schemas.openxmlformats.org/drawingml/2006/main" xmlns:p="http://schemas.openxmlformats.org/presentationml/2006/main">
   <p:cSld>

</xml_diff>